<commit_message>
adapt to newest ppt
</commit_message>
<xml_diff>
--- a/CRIS_week14.pptx
+++ b/CRIS_week14.pptx
@@ -8,8 +8,9 @@
     <p:sldId id="256" r:id="rId2"/>
     <p:sldId id="259" r:id="rId3"/>
     <p:sldId id="260" r:id="rId4"/>
-    <p:sldId id="257" r:id="rId5"/>
-    <p:sldId id="258" r:id="rId6"/>
+    <p:sldId id="261" r:id="rId5"/>
+    <p:sldId id="257" r:id="rId6"/>
+    <p:sldId id="258" r:id="rId7"/>
   </p:sldIdLst>
   <p:sldSz cx="12192000" cy="6858000"/>
   <p:notesSz cx="6858000" cy="9144000"/>
@@ -263,7 +264,7 @@
           <a:p>
             <a:fld id="{4E1F1B7E-6966-4D66-AF8F-551D238877EA}" type="datetimeFigureOut">
               <a:rPr lang="zh-CN" altLang="en-US" smtClean="0"/>
-              <a:t>2026/6/27</a:t>
+              <a:t>2026/6/29</a:t>
             </a:fld>
             <a:endParaRPr lang="zh-CN" altLang="en-US"/>
           </a:p>
@@ -461,7 +462,7 @@
           <a:p>
             <a:fld id="{4E1F1B7E-6966-4D66-AF8F-551D238877EA}" type="datetimeFigureOut">
               <a:rPr lang="zh-CN" altLang="en-US" smtClean="0"/>
-              <a:t>2026/6/27</a:t>
+              <a:t>2026/6/29</a:t>
             </a:fld>
             <a:endParaRPr lang="zh-CN" altLang="en-US"/>
           </a:p>
@@ -669,7 +670,7 @@
           <a:p>
             <a:fld id="{4E1F1B7E-6966-4D66-AF8F-551D238877EA}" type="datetimeFigureOut">
               <a:rPr lang="zh-CN" altLang="en-US" smtClean="0"/>
-              <a:t>2026/6/27</a:t>
+              <a:t>2026/6/29</a:t>
             </a:fld>
             <a:endParaRPr lang="zh-CN" altLang="en-US"/>
           </a:p>
@@ -867,7 +868,7 @@
           <a:p>
             <a:fld id="{4E1F1B7E-6966-4D66-AF8F-551D238877EA}" type="datetimeFigureOut">
               <a:rPr lang="zh-CN" altLang="en-US" smtClean="0"/>
-              <a:t>2026/6/27</a:t>
+              <a:t>2026/6/29</a:t>
             </a:fld>
             <a:endParaRPr lang="zh-CN" altLang="en-US"/>
           </a:p>
@@ -1142,7 +1143,7 @@
           <a:p>
             <a:fld id="{4E1F1B7E-6966-4D66-AF8F-551D238877EA}" type="datetimeFigureOut">
               <a:rPr lang="zh-CN" altLang="en-US" smtClean="0"/>
-              <a:t>2026/6/27</a:t>
+              <a:t>2026/6/29</a:t>
             </a:fld>
             <a:endParaRPr lang="zh-CN" altLang="en-US"/>
           </a:p>
@@ -1407,7 +1408,7 @@
           <a:p>
             <a:fld id="{4E1F1B7E-6966-4D66-AF8F-551D238877EA}" type="datetimeFigureOut">
               <a:rPr lang="zh-CN" altLang="en-US" smtClean="0"/>
-              <a:t>2026/6/27</a:t>
+              <a:t>2026/6/29</a:t>
             </a:fld>
             <a:endParaRPr lang="zh-CN" altLang="en-US"/>
           </a:p>
@@ -1819,7 +1820,7 @@
           <a:p>
             <a:fld id="{4E1F1B7E-6966-4D66-AF8F-551D238877EA}" type="datetimeFigureOut">
               <a:rPr lang="zh-CN" altLang="en-US" smtClean="0"/>
-              <a:t>2026/6/27</a:t>
+              <a:t>2026/6/29</a:t>
             </a:fld>
             <a:endParaRPr lang="zh-CN" altLang="en-US"/>
           </a:p>
@@ -1960,7 +1961,7 @@
           <a:p>
             <a:fld id="{4E1F1B7E-6966-4D66-AF8F-551D238877EA}" type="datetimeFigureOut">
               <a:rPr lang="zh-CN" altLang="en-US" smtClean="0"/>
-              <a:t>2026/6/27</a:t>
+              <a:t>2026/6/29</a:t>
             </a:fld>
             <a:endParaRPr lang="zh-CN" altLang="en-US"/>
           </a:p>
@@ -2073,7 +2074,7 @@
           <a:p>
             <a:fld id="{4E1F1B7E-6966-4D66-AF8F-551D238877EA}" type="datetimeFigureOut">
               <a:rPr lang="zh-CN" altLang="en-US" smtClean="0"/>
-              <a:t>2026/6/27</a:t>
+              <a:t>2026/6/29</a:t>
             </a:fld>
             <a:endParaRPr lang="zh-CN" altLang="en-US"/>
           </a:p>
@@ -2384,7 +2385,7 @@
           <a:p>
             <a:fld id="{4E1F1B7E-6966-4D66-AF8F-551D238877EA}" type="datetimeFigureOut">
               <a:rPr lang="zh-CN" altLang="en-US" smtClean="0"/>
-              <a:t>2026/6/27</a:t>
+              <a:t>2026/6/29</a:t>
             </a:fld>
             <a:endParaRPr lang="zh-CN" altLang="en-US"/>
           </a:p>
@@ -2672,7 +2673,7 @@
           <a:p>
             <a:fld id="{4E1F1B7E-6966-4D66-AF8F-551D238877EA}" type="datetimeFigureOut">
               <a:rPr lang="zh-CN" altLang="en-US" smtClean="0"/>
-              <a:t>2026/6/27</a:t>
+              <a:t>2026/6/29</a:t>
             </a:fld>
             <a:endParaRPr lang="zh-CN" altLang="en-US"/>
           </a:p>
@@ -2913,7 +2914,7 @@
           <a:p>
             <a:fld id="{4E1F1B7E-6966-4D66-AF8F-551D238877EA}" type="datetimeFigureOut">
               <a:rPr lang="zh-CN" altLang="en-US" smtClean="0"/>
-              <a:t>2026/6/27</a:t>
+              <a:t>2026/6/29</a:t>
             </a:fld>
             <a:endParaRPr lang="zh-CN" altLang="en-US"/>
           </a:p>
@@ -3800,7 +3801,7 @@
         <p:spPr/>
         <p:txBody>
           <a:bodyPr>
-            <a:normAutofit/>
+            <a:normAutofit lnSpcReduction="10000"/>
           </a:bodyPr>
           <a:lstStyle/>
           <a:p>
@@ -3861,119 +3862,78 @@
               <a:rPr lang="zh-CN" altLang="en-US" sz="2000" dirty="0"/>
               <a:t>我们的结构：</a:t>
             </a:r>
+            <a:endParaRPr lang="en-US" altLang="zh-CN" sz="2000" dirty="0"/>
+          </a:p>
+          <a:p>
+            <a:endParaRPr lang="en-US" altLang="zh-CN" sz="2000" dirty="0"/>
+          </a:p>
+          <a:p>
+            <a:endParaRPr lang="en-US" altLang="zh-CN" sz="2000" dirty="0"/>
+          </a:p>
+          <a:p>
+            <a:endParaRPr lang="en-US" altLang="zh-CN" sz="2000" dirty="0"/>
+          </a:p>
+          <a:p>
+            <a:endParaRPr lang="en-US" altLang="zh-CN" sz="2000" dirty="0"/>
+          </a:p>
+          <a:p>
+            <a:endParaRPr lang="en-US" altLang="zh-CN" sz="2000" dirty="0"/>
+          </a:p>
+          <a:p>
+            <a:r>
+              <a:rPr lang="zh-CN" altLang="en-US" sz="2000" dirty="0"/>
+              <a:t>前向过程具体设计，可以把像素值展开成二进制串，用</a:t>
+            </a:r>
+            <a:r>
+              <a:rPr lang="en-US" altLang="zh-CN" sz="2000" dirty="0"/>
+              <a:t>D3PM</a:t>
+            </a:r>
+            <a:r>
+              <a:rPr lang="zh-CN" altLang="en-US" sz="2000" dirty="0"/>
+              <a:t>的</a:t>
+            </a:r>
+            <a:r>
+              <a:rPr lang="en-US" altLang="zh-CN" sz="2000" dirty="0"/>
+              <a:t>bit-flip</a:t>
+            </a:r>
+            <a:r>
+              <a:rPr lang="zh-CN" altLang="en-US" sz="2000" dirty="0"/>
+              <a:t>矩阵对每个</a:t>
+            </a:r>
+            <a:r>
+              <a:rPr lang="en-US" altLang="zh-CN" sz="2000" dirty="0"/>
+              <a:t>bit</a:t>
+            </a:r>
+            <a:r>
+              <a:rPr lang="zh-CN" altLang="en-US" sz="2000" dirty="0"/>
+              <a:t>单独做</a:t>
+            </a:r>
+            <a:r>
+              <a:rPr lang="en-US" altLang="zh-CN" sz="2000" dirty="0"/>
+              <a:t>flip</a:t>
+            </a:r>
+            <a:r>
+              <a:rPr lang="zh-CN" altLang="en-US" sz="2000" dirty="0"/>
+              <a:t>，淹没对抗扰动的影响</a:t>
+            </a:r>
+            <a:endParaRPr lang="en-US" altLang="zh-CN" sz="2000" dirty="0"/>
+          </a:p>
+          <a:p>
+            <a:r>
+              <a:rPr lang="zh-CN" altLang="en-US" sz="2000" dirty="0"/>
+              <a:t>或者在</a:t>
+            </a:r>
             <a:r>
               <a:rPr lang="en-US" altLang="zh-CN" sz="2000" dirty="0" err="1"/>
-              <a:t>x</a:t>
-            </a:r>
-            <a:r>
-              <a:rPr lang="en-US" altLang="zh-CN" sz="2000" baseline="-25000" dirty="0" err="1"/>
-              <a:t>adv</a:t>
+              <a:t>vqvae</a:t>
             </a:r>
             <a:r>
               <a:rPr lang="zh-CN" altLang="en-US" sz="2000" dirty="0"/>
-              <a:t>（对抗）→ </a:t>
-            </a:r>
-            <a:r>
-              <a:rPr lang="en-US" altLang="zh-CN" sz="2000" dirty="0"/>
-              <a:t>binary</a:t>
-            </a:r>
-            <a:r>
-              <a:rPr lang="zh-CN" altLang="en-US" sz="2000" dirty="0"/>
-              <a:t>化</a:t>
-            </a:r>
-            <a:r>
-              <a:rPr lang="en-US" altLang="zh-CN" sz="2000" dirty="0"/>
-              <a:t>+</a:t>
-            </a:r>
-            <a:r>
-              <a:rPr lang="zh-CN" altLang="en-US" sz="2000" dirty="0"/>
-              <a:t>加噪 → </a:t>
-            </a:r>
-            <a:r>
-              <a:rPr lang="en-US" altLang="zh-CN" sz="2000" dirty="0" err="1"/>
-              <a:t>x</a:t>
-            </a:r>
-            <a:r>
-              <a:rPr lang="en-US" altLang="zh-CN" sz="2000" baseline="-25000" dirty="0" err="1"/>
-              <a:t>t</a:t>
-            </a:r>
-            <a:r>
-              <a:rPr lang="en-US" altLang="zh-CN" sz="2000" dirty="0"/>
-              <a:t> → </a:t>
-            </a:r>
-            <a:r>
-              <a:rPr lang="zh-CN" altLang="en-US" sz="2000" dirty="0"/>
-              <a:t>去噪 → 重建</a:t>
-            </a:r>
-            <a:r>
-              <a:rPr lang="en-US" altLang="zh-CN" sz="2000" dirty="0" err="1"/>
-              <a:t>x</a:t>
-            </a:r>
-            <a:r>
-              <a:rPr lang="en-US" altLang="zh-CN" sz="2000" baseline="-25000" dirty="0" err="1"/>
-              <a:t>clean</a:t>
-            </a:r>
-            <a:endParaRPr lang="en-US" altLang="zh-CN" sz="2000" baseline="-25000" dirty="0"/>
-          </a:p>
-          <a:p>
-            <a:r>
-              <a:rPr lang="zh-CN" altLang="en-US" sz="2000" dirty="0"/>
-              <a:t>冷扩散通过用确定性图像变换（如模糊、遮罩、降采样、像素化或变形态）替代基于噪声的退化，同时学习反向算子以恢复原始图像。</a:t>
-            </a:r>
-            <a:endParaRPr lang="en-US" altLang="zh-CN" sz="2000" dirty="0"/>
-          </a:p>
-          <a:p>
-            <a:r>
-              <a:rPr lang="zh-CN" altLang="en-US" sz="2000" dirty="0"/>
-              <a:t>可以借鉴冷扩散的思路，把对抗扰动的添加看作一次退化操作，把前向扩散转化为</a:t>
-            </a:r>
-            <a:r>
-              <a:rPr lang="en-US" altLang="zh-CN" sz="2000" dirty="0" err="1"/>
-              <a:t>x</a:t>
-            </a:r>
-            <a:r>
-              <a:rPr lang="en-US" altLang="zh-CN" sz="2000" baseline="-25000" dirty="0" err="1"/>
-              <a:t>clean</a:t>
-            </a:r>
-            <a:r>
-              <a:rPr lang="en-US" altLang="zh-CN" sz="2000" dirty="0"/>
-              <a:t> → </a:t>
-            </a:r>
-            <a:r>
-              <a:rPr lang="zh-CN" altLang="en-US" sz="2000" dirty="0"/>
-              <a:t>加对抗噪声 → </a:t>
-            </a:r>
-            <a:r>
-              <a:rPr lang="en-US" altLang="zh-CN" sz="2000" dirty="0" err="1"/>
-              <a:t>x</a:t>
-            </a:r>
-            <a:r>
-              <a:rPr lang="en-US" altLang="zh-CN" sz="2000" baseline="-25000" dirty="0" err="1"/>
-              <a:t>adv</a:t>
-            </a:r>
-            <a:r>
-              <a:rPr lang="en-US" altLang="zh-CN" sz="2000" dirty="0"/>
-              <a:t> → </a:t>
-            </a:r>
-            <a:r>
-              <a:rPr lang="zh-CN" altLang="en-US" sz="2000" dirty="0"/>
-              <a:t>继续</a:t>
-            </a:r>
-            <a:r>
-              <a:rPr lang="en-US" altLang="zh-CN" sz="2000" dirty="0"/>
-              <a:t>binary</a:t>
-            </a:r>
-            <a:r>
-              <a:rPr lang="zh-CN" altLang="en-US" sz="2000" dirty="0"/>
-              <a:t>加噪 → </a:t>
-            </a:r>
-            <a:r>
-              <a:rPr lang="en-US" altLang="zh-CN" sz="2000" dirty="0" err="1"/>
-              <a:t>x</a:t>
-            </a:r>
-            <a:r>
-              <a:rPr lang="en-US" altLang="zh-CN" sz="2000" baseline="-25000" dirty="0" err="1"/>
-              <a:t>t</a:t>
+              <a:t>的前空间上操作，</a:t>
+            </a:r>
+            <a:r>
+              <a:rPr lang="zh-CN" altLang="zh-CN" sz="2000" dirty="0"/>
+              <a:t>先用预训练VQ-VAE把图像encode成codebook indices，然后在indices上做D3PM的uniform或bit-flip加噪。</a:t>
             </a:r>
             <a:endParaRPr lang="zh-CN" altLang="en-US" sz="2000" dirty="0"/>
           </a:p>
@@ -3981,10 +3941,10 @@
       </p:sp>
       <p:pic>
         <p:nvPicPr>
-          <p:cNvPr id="5" name="图片 4">
-            <a:extLst>
-              <a:ext uri="{FF2B5EF4-FFF2-40B4-BE49-F238E27FC236}">
-                <a16:creationId xmlns:a16="http://schemas.microsoft.com/office/drawing/2014/main" id="{1567DDE4-D447-0883-5607-06A8AFB85399}"/>
+          <p:cNvPr id="6" name="图片 5">
+            <a:extLst>
+              <a:ext uri="{FF2B5EF4-FFF2-40B4-BE49-F238E27FC236}">
+                <a16:creationId xmlns:a16="http://schemas.microsoft.com/office/drawing/2014/main" id="{7E7C0B06-9FDC-4233-01B1-11FCB9F9EEE6}"/>
               </a:ext>
             </a:extLst>
           </p:cNvPr>
@@ -4001,8 +3961,8 @@
         </p:blipFill>
         <p:spPr>
           <a:xfrm>
-            <a:off x="6479582" y="4092767"/>
-            <a:ext cx="4274734" cy="2462384"/>
+            <a:off x="1532845" y="2853581"/>
+            <a:ext cx="5466670" cy="1496622"/>
           </a:xfrm>
           <a:prstGeom prst="rect">
             <a:avLst/>
@@ -4064,186 +4024,164 @@
           </a:p>
         </p:txBody>
       </p:sp>
-      <mc:AlternateContent xmlns:mc="http://schemas.openxmlformats.org/markup-compatibility/2006">
-        <mc:Choice xmlns:a14="http://schemas.microsoft.com/office/drawing/2010/main" Requires="a14">
-          <p:sp>
-            <p:nvSpPr>
-              <p:cNvPr id="3" name="内容占位符 2">
-                <a:extLst>
-                  <a:ext uri="{FF2B5EF4-FFF2-40B4-BE49-F238E27FC236}">
-                    <a16:creationId xmlns:a16="http://schemas.microsoft.com/office/drawing/2014/main" id="{B035F502-2504-4380-D34D-0FB534453F74}"/>
-                  </a:ext>
-                </a:extLst>
-              </p:cNvPr>
-              <p:cNvSpPr>
-                <a:spLocks noGrp="1"/>
-              </p:cNvSpPr>
-              <p:nvPr>
-                <p:ph idx="1"/>
-              </p:nvPr>
-            </p:nvSpPr>
-            <p:spPr/>
-            <p:txBody>
-              <a:bodyPr/>
-              <a:lstStyle/>
-              <a:p>
-                <a:r>
-                  <a:rPr lang="zh-CN" altLang="en-US" dirty="0"/>
-                  <a:t>两级退化：</a:t>
-                </a:r>
-                <a:endParaRPr lang="en-US" altLang="zh-CN" dirty="0"/>
-              </a:p>
-              <a:p>
-                <a:r>
-                  <a:rPr lang="zh-CN" altLang="en-US" sz="2000" dirty="0"/>
-                  <a:t>第一级退化就是对抗样本的添加，把干净样本</a:t>
-                </a:r>
-                <a:r>
-                  <a:rPr lang="en-US" altLang="zh-CN" sz="2000" dirty="0"/>
-                  <a:t>x</a:t>
-                </a:r>
-                <a:r>
-                  <a:rPr lang="en-US" altLang="zh-CN" sz="2000" baseline="-25000" dirty="0"/>
-                  <a:t>0</a:t>
-                </a:r>
-                <a:r>
-                  <a:rPr lang="zh-CN" altLang="en-US" sz="2000" dirty="0"/>
-                  <a:t>推入对抗样本所在的区域</a:t>
-                </a:r>
-                <a:endParaRPr lang="en-US" altLang="zh-CN" sz="2000" dirty="0"/>
-              </a:p>
-              <a:p>
-                <a:r>
-                  <a:rPr lang="zh-CN" altLang="en-US" sz="2000" dirty="0"/>
-                  <a:t>第二级退化则是</a:t>
-                </a:r>
-                <a:r>
-                  <a:rPr lang="en-US" altLang="zh-CN" sz="2000" dirty="0"/>
-                  <a:t>binary</a:t>
-                </a:r>
-                <a:r>
-                  <a:rPr lang="zh-CN" altLang="en-US" sz="2000" dirty="0"/>
-                  <a:t>离散化的过程，</a:t>
-                </a:r>
-                <a:r>
-                  <a:rPr lang="zh-CN" altLang="zh-CN" sz="2000" dirty="0"/>
-                  <a:t>即D3PM的bit-flip过程，随着</a:t>
-                </a:r>
-                <a14:m>
-                  <m:oMath xmlns:m="http://schemas.openxmlformats.org/officeDocument/2006/math">
-                    <m:r>
-                      <a:rPr lang="zh-CN" altLang="en-US" i="1"/>
-                      <m:t>𝑡</m:t>
-                    </m:r>
-                  </m:oMath>
-                </a14:m>
-                <a:r>
-                  <a:rPr lang="zh-CN" altLang="zh-CN" sz="2000" dirty="0"/>
-                  <a:t>增大，越来越多的bit被随机翻转，最终收敛到</a:t>
-                </a:r>
-                <a14:m>
-                  <m:oMath xmlns:m="http://schemas.openxmlformats.org/officeDocument/2006/math">
-                    <m:r>
-                      <m:rPr>
-                        <m:nor/>
-                      </m:rPr>
-                      <a:rPr lang="en-US" altLang="zh-CN" sz="2000" b="0"/>
-                      <m:t>Bernoulli</m:t>
-                    </m:r>
-                    <m:d>
-                      <m:dPr>
-                        <m:ctrlPr>
-                          <a:rPr lang="zh-CN" altLang="en-US" i="1"/>
-                        </m:ctrlPr>
-                      </m:dPr>
-                      <m:e>
-                        <m:r>
-                          <a:rPr lang="en-US" altLang="zh-CN"/>
-                          <m:t>0.5</m:t>
-                        </m:r>
-                      </m:e>
-                    </m:d>
-                  </m:oMath>
-                </a14:m>
-                <a:r>
-                  <a:rPr lang="zh-CN" altLang="zh-CN" sz="2000" dirty="0"/>
-                  <a:t>。</a:t>
-                </a:r>
-                <a:endParaRPr lang="en-US" altLang="zh-CN" sz="2000" dirty="0"/>
-              </a:p>
-            </p:txBody>
-          </p:sp>
-        </mc:Choice>
-        <mc:Fallback>
-          <p:sp>
-            <p:nvSpPr>
-              <p:cNvPr id="3" name="内容占位符 2">
-                <a:extLst>
-                  <a:ext uri="{FF2B5EF4-FFF2-40B4-BE49-F238E27FC236}">
-                    <a16:creationId xmlns:a16="http://schemas.microsoft.com/office/drawing/2014/main" id="{B035F502-2504-4380-D34D-0FB534453F74}"/>
-                  </a:ext>
-                </a:extLst>
-              </p:cNvPr>
-              <p:cNvSpPr>
-                <a:spLocks noGrp="1" noRot="1" noChangeAspect="1" noMove="1" noResize="1" noEditPoints="1" noAdjustHandles="1" noChangeArrowheads="1" noChangeShapeType="1" noTextEdit="1"/>
-              </p:cNvSpPr>
-              <p:nvPr>
-                <p:ph idx="1"/>
-              </p:nvPr>
-            </p:nvSpPr>
-            <p:spPr>
-              <a:blipFill>
-                <a:blip r:embed="rId2"/>
-                <a:stretch>
-                  <a:fillRect l="-1043" t="-2521"/>
-                </a:stretch>
-              </a:blipFill>
-            </p:spPr>
-            <p:txBody>
-              <a:bodyPr/>
-              <a:lstStyle/>
-              <a:p>
-                <a:r>
-                  <a:rPr lang="zh-CN" altLang="en-US">
-                    <a:noFill/>
-                  </a:rPr>
-                  <a:t> </a:t>
-                </a:r>
-              </a:p>
-            </p:txBody>
-          </p:sp>
-        </mc:Fallback>
-      </mc:AlternateContent>
-      <p:pic>
-        <p:nvPicPr>
-          <p:cNvPr id="5" name="图片 4">
-            <a:extLst>
-              <a:ext uri="{FF2B5EF4-FFF2-40B4-BE49-F238E27FC236}">
-                <a16:creationId xmlns:a16="http://schemas.microsoft.com/office/drawing/2014/main" id="{DACC5A27-F11B-B725-9FE6-3344FFEFEB10}"/>
-              </a:ext>
-            </a:extLst>
-          </p:cNvPr>
-          <p:cNvPicPr>
-            <a:picLocks noChangeAspect="1"/>
-          </p:cNvPicPr>
-          <p:nvPr/>
-        </p:nvPicPr>
-        <p:blipFill>
-          <a:blip r:embed="rId3"/>
-          <a:stretch>
-            <a:fillRect/>
-          </a:stretch>
-        </p:blipFill>
-        <p:spPr>
-          <a:xfrm>
-            <a:off x="1047750" y="4480064"/>
-            <a:ext cx="8205107" cy="993409"/>
-          </a:xfrm>
-          <a:prstGeom prst="rect">
-            <a:avLst/>
-          </a:prstGeom>
-        </p:spPr>
-      </p:pic>
+      <p:sp>
+        <p:nvSpPr>
+          <p:cNvPr id="3" name="内容占位符 2">
+            <a:extLst>
+              <a:ext uri="{FF2B5EF4-FFF2-40B4-BE49-F238E27FC236}">
+                <a16:creationId xmlns:a16="http://schemas.microsoft.com/office/drawing/2014/main" id="{B035F502-2504-4380-D34D-0FB534453F74}"/>
+              </a:ext>
+            </a:extLst>
+          </p:cNvPr>
+          <p:cNvSpPr>
+            <a:spLocks noGrp="1"/>
+          </p:cNvSpPr>
+          <p:nvPr>
+            <p:ph idx="1"/>
+          </p:nvPr>
+        </p:nvSpPr>
+        <p:spPr/>
+        <p:txBody>
+          <a:bodyPr/>
+          <a:lstStyle/>
+          <a:p>
+            <a:r>
+              <a:rPr lang="zh-CN" altLang="en-US" sz="2000" dirty="0"/>
+              <a:t>反向过程：</a:t>
+            </a:r>
+            <a:endParaRPr lang="en-US" altLang="zh-CN" sz="2000" dirty="0"/>
+          </a:p>
+          <a:p>
+            <a:r>
+              <a:rPr lang="zh-CN" altLang="en-US" sz="2000" dirty="0"/>
+              <a:t>可以沿用</a:t>
+            </a:r>
+            <a:r>
+              <a:rPr lang="en-US" altLang="zh-CN" sz="2000" dirty="0"/>
+              <a:t>D3PM</a:t>
+            </a:r>
+            <a:r>
+              <a:rPr lang="zh-CN" altLang="en-US" sz="2000" dirty="0"/>
+              <a:t>的</a:t>
+            </a:r>
+            <a:r>
+              <a:rPr lang="en-US" altLang="zh-CN" sz="2000" dirty="0"/>
+              <a:t>ELBO</a:t>
+            </a:r>
+            <a:r>
+              <a:rPr lang="zh-CN" altLang="en-US" sz="2000" dirty="0"/>
+              <a:t>，预测原始图像</a:t>
+            </a:r>
+            <a:r>
+              <a:rPr lang="en-US" altLang="zh-CN" sz="2000" dirty="0"/>
+              <a:t>x</a:t>
+            </a:r>
+            <a:r>
+              <a:rPr lang="en-US" altLang="zh-CN" sz="2000" baseline="-25000" dirty="0"/>
+              <a:t>0</a:t>
+            </a:r>
+            <a:r>
+              <a:rPr lang="zh-CN" altLang="en-US" sz="2000" dirty="0"/>
+              <a:t>。</a:t>
+            </a:r>
+            <a:endParaRPr lang="en-US" altLang="zh-CN" sz="2000" dirty="0"/>
+          </a:p>
+          <a:p>
+            <a:r>
+              <a:rPr lang="zh-CN" altLang="en-US" sz="2000" dirty="0"/>
+              <a:t>加噪到第几步开始去噪流程需要仔细选择。</a:t>
+            </a:r>
+            <a:endParaRPr lang="en-US" altLang="zh-CN" sz="2000" dirty="0"/>
+          </a:p>
+          <a:p>
+            <a:r>
+              <a:rPr lang="en-US" altLang="zh-CN" sz="2000" dirty="0"/>
+              <a:t>Binary</a:t>
+            </a:r>
+            <a:r>
+              <a:rPr lang="zh-CN" altLang="en-US" sz="2000" dirty="0"/>
+              <a:t>加噪相较于高斯加噪的优势在于</a:t>
+            </a:r>
+            <a:r>
+              <a:rPr lang="en-US" altLang="zh-CN" sz="2000" dirty="0"/>
+              <a:t>binary flip</a:t>
+            </a:r>
+            <a:r>
+              <a:rPr lang="zh-CN" altLang="en-US" sz="2000" dirty="0"/>
+              <a:t>是离散的，而高斯加噪对每个比特的影响是耦合的。</a:t>
+            </a:r>
+            <a:r>
+              <a:rPr lang="zh-CN" altLang="zh-CN" sz="2000" dirty="0"/>
+              <a:t>高斯加噪通过数值幅度作用，无法在淹没低幅度对抗扰动的同时保护高位bit；binary flip通过直接操作bit，提供了一种不同的噪声结构，但它本身并不天然地优先保护高位bit。</a:t>
+            </a:r>
+            <a:endParaRPr lang="en-US" altLang="zh-CN" sz="2000" dirty="0"/>
+          </a:p>
+          <a:p>
+            <a:endParaRPr lang="en-US" altLang="zh-CN" sz="2000" dirty="0"/>
+          </a:p>
+          <a:p>
+            <a:r>
+              <a:rPr lang="zh-CN" altLang="en-US" sz="2000" dirty="0"/>
+              <a:t>需要论证：</a:t>
+            </a:r>
+            <a:endParaRPr lang="en-US" altLang="zh-CN" sz="2000" dirty="0"/>
+          </a:p>
+          <a:p>
+            <a:r>
+              <a:rPr lang="zh-CN" altLang="en-US" sz="2000" dirty="0"/>
+              <a:t>在一定的加噪步骤后，</a:t>
+            </a:r>
+            <a:r>
+              <a:rPr lang="en-US" altLang="zh-CN" sz="2000" dirty="0"/>
+              <a:t>x</a:t>
+            </a:r>
+            <a:r>
+              <a:rPr lang="en-US" altLang="zh-CN" sz="2000" baseline="-25000" dirty="0"/>
+              <a:t>0</a:t>
+            </a:r>
+            <a:r>
+              <a:rPr lang="zh-CN" altLang="en-US" sz="2000" dirty="0"/>
+              <a:t>和</a:t>
+            </a:r>
+            <a:r>
+              <a:rPr lang="en-US" altLang="zh-CN" sz="2000" dirty="0" err="1"/>
+              <a:t>x</a:t>
+            </a:r>
+            <a:r>
+              <a:rPr lang="en-US" altLang="zh-CN" sz="2000" baseline="-25000" dirty="0" err="1"/>
+              <a:t>adv</a:t>
+            </a:r>
+            <a:r>
+              <a:rPr lang="zh-CN" altLang="en-US" sz="2000" dirty="0"/>
+              <a:t>的分布差异足够小，可以通过</a:t>
+            </a:r>
+            <a:r>
+              <a:rPr lang="en-US" altLang="zh-CN" sz="2000" dirty="0"/>
+              <a:t>KL</a:t>
+            </a:r>
+            <a:r>
+              <a:rPr lang="zh-CN" altLang="en-US" sz="2000" dirty="0"/>
+              <a:t>散度或者直接实验验证。</a:t>
+            </a:r>
+            <a:endParaRPr lang="en-US" altLang="zh-CN" sz="2000" dirty="0"/>
+          </a:p>
+          <a:p>
+            <a:r>
+              <a:rPr lang="zh-CN" altLang="en-US" sz="2000" dirty="0"/>
+              <a:t>适应性攻击的威胁如何降低：针对</a:t>
+            </a:r>
+            <a:r>
+              <a:rPr lang="en-US" altLang="zh-CN" sz="2000" dirty="0"/>
+              <a:t>binary</a:t>
+            </a:r>
+            <a:r>
+              <a:rPr lang="zh-CN" altLang="en-US" sz="2000" dirty="0"/>
+              <a:t>分布在高有效位施加的攻击难以被淹没。</a:t>
+            </a:r>
+            <a:endParaRPr lang="en-US" altLang="zh-CN" sz="2000" dirty="0"/>
+          </a:p>
+        </p:txBody>
+      </p:sp>
     </p:spTree>
     <p:extLst>
       <p:ext uri="{BB962C8B-B14F-4D97-AF65-F5344CB8AC3E}">
@@ -4279,6 +4217,261 @@
           <p:cNvPr id="2" name="标题 1">
             <a:extLst>
               <a:ext uri="{FF2B5EF4-FFF2-40B4-BE49-F238E27FC236}">
+                <a16:creationId xmlns:a16="http://schemas.microsoft.com/office/drawing/2014/main" id="{208AE9CB-CB5C-55D3-060F-5F277358FA87}"/>
+              </a:ext>
+            </a:extLst>
+          </p:cNvPr>
+          <p:cNvSpPr>
+            <a:spLocks noGrp="1"/>
+          </p:cNvSpPr>
+          <p:nvPr>
+            <p:ph type="title"/>
+          </p:nvPr>
+        </p:nvSpPr>
+        <p:spPr/>
+        <p:txBody>
+          <a:bodyPr/>
+          <a:lstStyle/>
+          <a:p>
+            <a:r>
+              <a:rPr lang="en-US" altLang="zh-CN" dirty="0"/>
+              <a:t>D3PM</a:t>
+            </a:r>
+            <a:r>
+              <a:rPr lang="zh-CN" altLang="en-US" dirty="0"/>
+              <a:t>（离散去噪模型）</a:t>
+            </a:r>
+          </a:p>
+        </p:txBody>
+      </p:sp>
+      <p:pic>
+        <p:nvPicPr>
+          <p:cNvPr id="5" name="内容占位符 4">
+            <a:extLst>
+              <a:ext uri="{FF2B5EF4-FFF2-40B4-BE49-F238E27FC236}">
+                <a16:creationId xmlns:a16="http://schemas.microsoft.com/office/drawing/2014/main" id="{F864F110-2E95-1B5C-5360-5F97FBAF8EA1}"/>
+              </a:ext>
+            </a:extLst>
+          </p:cNvPr>
+          <p:cNvPicPr>
+            <a:picLocks noGrp="1" noChangeAspect="1"/>
+          </p:cNvPicPr>
+          <p:nvPr>
+            <p:ph idx="1"/>
+          </p:nvPr>
+        </p:nvPicPr>
+        <p:blipFill>
+          <a:blip r:embed="rId2"/>
+          <a:stretch>
+            <a:fillRect/>
+          </a:stretch>
+        </p:blipFill>
+        <p:spPr>
+          <a:xfrm>
+            <a:off x="1883229" y="3719730"/>
+            <a:ext cx="7064829" cy="1020893"/>
+          </a:xfrm>
+          <a:prstGeom prst="rect">
+            <a:avLst/>
+          </a:prstGeom>
+        </p:spPr>
+      </p:pic>
+      <p:sp>
+        <p:nvSpPr>
+          <p:cNvPr id="6" name="文本框 5">
+            <a:extLst>
+              <a:ext uri="{FF2B5EF4-FFF2-40B4-BE49-F238E27FC236}">
+                <a16:creationId xmlns:a16="http://schemas.microsoft.com/office/drawing/2014/main" id="{8E94C0EF-8E02-CE86-7D93-ECE0088154FB}"/>
+              </a:ext>
+            </a:extLst>
+          </p:cNvPr>
+          <p:cNvSpPr txBox="1"/>
+          <p:nvPr/>
+        </p:nvSpPr>
+        <p:spPr>
+          <a:xfrm>
+            <a:off x="859971" y="2041071"/>
+            <a:ext cx="9769929" cy="4524315"/>
+          </a:xfrm>
+          <a:prstGeom prst="rect">
+            <a:avLst/>
+          </a:prstGeom>
+          <a:noFill/>
+        </p:spPr>
+        <p:txBody>
+          <a:bodyPr wrap="square" rtlCol="0">
+            <a:spAutoFit/>
+          </a:bodyPr>
+          <a:lstStyle/>
+          <a:p>
+            <a:r>
+              <a:rPr lang="zh-CN" altLang="en-US" dirty="0"/>
+              <a:t>尝试将扩散机制推广到离散空间，支持对文本等离散数据的生成。它的核心思想是用一个转移矩阵</a:t>
+            </a:r>
+            <a:r>
+              <a:rPr lang="en-US" altLang="zh-CN" dirty="0"/>
+              <a:t>Q</a:t>
+            </a:r>
+            <a:r>
+              <a:rPr lang="zh-CN" altLang="en-US" dirty="0"/>
+              <a:t>作为马尔可夫过程中的转移概率。</a:t>
+            </a:r>
+            <a:endParaRPr lang="en-US" altLang="zh-CN" dirty="0"/>
+          </a:p>
+          <a:p>
+            <a:r>
+              <a:rPr lang="en-US" altLang="zh-CN" dirty="0"/>
+              <a:t>D3PM</a:t>
+            </a:r>
+            <a:r>
+              <a:rPr lang="zh-CN" altLang="en-US" dirty="0"/>
+              <a:t>支持多种转移矩阵的设计。我们可以尝试</a:t>
+            </a:r>
+            <a:r>
+              <a:rPr lang="en-US" altLang="zh-CN" dirty="0"/>
+              <a:t>bit-flip</a:t>
+            </a:r>
+            <a:r>
+              <a:rPr lang="zh-CN" altLang="en-US" dirty="0"/>
+              <a:t>的转移矩阵。引入</a:t>
+            </a:r>
+            <a:r>
+              <a:rPr lang="en-US" altLang="zh-CN" dirty="0"/>
+              <a:t>D3PM</a:t>
+            </a:r>
+            <a:r>
+              <a:rPr lang="zh-CN" altLang="en-US" dirty="0"/>
+              <a:t>后，</a:t>
+            </a:r>
+            <a:r>
+              <a:rPr lang="en-US" altLang="zh-CN" dirty="0"/>
+              <a:t>ELBO</a:t>
+            </a:r>
+            <a:r>
+              <a:rPr lang="zh-CN" altLang="en-US" dirty="0"/>
+              <a:t>可以正常推到，训练慕白哦也与</a:t>
+            </a:r>
+            <a:r>
+              <a:rPr lang="en-US" altLang="zh-CN" dirty="0"/>
+              <a:t>DDPM</a:t>
+            </a:r>
+            <a:r>
+              <a:rPr lang="zh-CN" altLang="en-US" dirty="0"/>
+              <a:t>中的一致，</a:t>
+            </a:r>
+            <a:r>
+              <a:rPr lang="zh-CN" altLang="zh-CN" dirty="0"/>
+              <a:t>训练只需要干净图像，不需要对抗样本的配对数据，这是相比有监督净化方法的重要优势。</a:t>
+            </a:r>
+            <a:endParaRPr lang="en-US" altLang="zh-CN" dirty="0"/>
+          </a:p>
+          <a:p>
+            <a:endParaRPr lang="en-US" altLang="zh-CN" dirty="0"/>
+          </a:p>
+          <a:p>
+            <a:endParaRPr lang="en-US" altLang="zh-CN" dirty="0"/>
+          </a:p>
+          <a:p>
+            <a:endParaRPr lang="en-US" altLang="zh-CN" dirty="0"/>
+          </a:p>
+          <a:p>
+            <a:endParaRPr lang="en-US" altLang="zh-CN" dirty="0"/>
+          </a:p>
+          <a:p>
+            <a:endParaRPr lang="en-US" altLang="zh-CN" dirty="0"/>
+          </a:p>
+          <a:p>
+            <a:endParaRPr lang="en-US" altLang="zh-CN" dirty="0"/>
+          </a:p>
+          <a:p>
+            <a:r>
+              <a:rPr lang="zh-CN" altLang="en-US" dirty="0"/>
+              <a:t>可以在现有的</a:t>
+            </a:r>
+            <a:r>
+              <a:rPr lang="en-US" altLang="zh-CN" dirty="0"/>
+              <a:t>D3PM</a:t>
+            </a:r>
+            <a:r>
+              <a:rPr lang="zh-CN" altLang="en-US" dirty="0"/>
+              <a:t>实现中进行改动。我们采用的</a:t>
+            </a:r>
+            <a:r>
+              <a:rPr lang="en-US" altLang="zh-CN" dirty="0"/>
+              <a:t>binary flip</a:t>
+            </a:r>
+            <a:r>
+              <a:rPr lang="zh-CN" altLang="en-US" dirty="0"/>
+              <a:t>矩阵比一般的</a:t>
+            </a:r>
+            <a:r>
+              <a:rPr lang="en-US" altLang="zh-CN" dirty="0"/>
+              <a:t>uniform</a:t>
+            </a:r>
+            <a:r>
+              <a:rPr lang="zh-CN" altLang="en-US" dirty="0"/>
+              <a:t>或</a:t>
+            </a:r>
+            <a:r>
+              <a:rPr lang="en-US" altLang="zh-CN" dirty="0"/>
+              <a:t>absorbing</a:t>
+            </a:r>
+            <a:r>
+              <a:rPr lang="zh-CN" altLang="en-US" dirty="0"/>
+              <a:t>矩阵更加简单，可以直接替换。</a:t>
+            </a:r>
+            <a:endParaRPr lang="en-US" altLang="zh-CN" dirty="0"/>
+          </a:p>
+          <a:p>
+            <a:r>
+              <a:rPr lang="zh-CN" altLang="zh-CN" dirty="0"/>
+              <a:t>dataloader、optimizer、EMA、checkpoint保存这些工程部分可以</a:t>
+            </a:r>
+            <a:r>
+              <a:rPr lang="zh-CN" altLang="en-US" dirty="0"/>
+              <a:t>复用，但采样推理部分需要重写</a:t>
+            </a:r>
+          </a:p>
+          <a:p>
+            <a:endParaRPr lang="en-US" altLang="zh-CN" dirty="0"/>
+          </a:p>
+        </p:txBody>
+      </p:sp>
+    </p:spTree>
+    <p:extLst>
+      <p:ext uri="{BB962C8B-B14F-4D97-AF65-F5344CB8AC3E}">
+        <p14:creationId xmlns:p14="http://schemas.microsoft.com/office/powerpoint/2010/main" val="2991367123"/>
+      </p:ext>
+    </p:extLst>
+  </p:cSld>
+  <p:clrMapOvr>
+    <a:masterClrMapping/>
+  </p:clrMapOvr>
+</p:sld>
+</file>
+
+<file path=ppt/slides/slide5.xml><?xml version="1.0" encoding="utf-8"?>
+<p:sld xmlns:a="http://schemas.openxmlformats.org/drawingml/2006/main" xmlns:r="http://schemas.openxmlformats.org/officeDocument/2006/relationships" xmlns:p="http://schemas.openxmlformats.org/presentationml/2006/main">
+  <p:cSld>
+    <p:spTree>
+      <p:nvGrpSpPr>
+        <p:cNvPr id="1" name=""/>
+        <p:cNvGrpSpPr/>
+        <p:nvPr/>
+      </p:nvGrpSpPr>
+      <p:grpSpPr>
+        <a:xfrm>
+          <a:off x="0" y="0"/>
+          <a:ext cx="0" cy="0"/>
+          <a:chOff x="0" y="0"/>
+          <a:chExt cx="0" cy="0"/>
+        </a:xfrm>
+      </p:grpSpPr>
+      <p:sp>
+        <p:nvSpPr>
+          <p:cNvPr id="2" name="标题 1">
+            <a:extLst>
+              <a:ext uri="{FF2B5EF4-FFF2-40B4-BE49-F238E27FC236}">
                 <a16:creationId xmlns:a16="http://schemas.microsoft.com/office/drawing/2014/main" id="{990CA416-C171-507E-FB46-41D2797EB652}"/>
               </a:ext>
             </a:extLst>
@@ -4319,77 +4512,82 @@
             <p:ph idx="1"/>
           </p:nvPr>
         </p:nvSpPr>
-        <p:spPr/>
-        <p:txBody>
-          <a:bodyPr/>
-          <a:lstStyle/>
-          <a:p>
-            <a:r>
-              <a:rPr lang="zh-CN" altLang="zh-CN" sz="2000" b="1" dirty="0"/>
+        <p:spPr>
+          <a:xfrm>
+            <a:off x="838199" y="1825625"/>
+            <a:ext cx="9960429" cy="4351338"/>
+          </a:xfrm>
+        </p:spPr>
+        <p:txBody>
+          <a:bodyPr/>
+          <a:lstStyle/>
+          <a:p>
+            <a:r>
+              <a:rPr lang="zh-CN" altLang="zh-CN" sz="2400" b="1" dirty="0"/>
               <a:t>和ddpm的区别</a:t>
             </a:r>
             <a:br>
-              <a:rPr lang="zh-CN" altLang="zh-CN" sz="2000" b="1" dirty="0"/>
+              <a:rPr lang="zh-CN" altLang="zh-CN" sz="2400" b="1" dirty="0"/>
             </a:br>
-            <a:endParaRPr lang="zh-CN" altLang="zh-CN" sz="2000" b="1" dirty="0"/>
+            <a:endParaRPr lang="zh-CN" altLang="zh-CN" sz="2400" b="1" dirty="0"/>
           </a:p>
           <a:p>
             <a:pPr lvl="1"/>
             <a:r>
-              <a:rPr lang="zh-CN" altLang="zh-CN" sz="2000" dirty="0"/>
+              <a:rPr lang="zh-CN" altLang="zh-CN" dirty="0"/>
               <a:t>ddpm是在连续空间下进行加噪，VQ-diffusion在离散空间中进行加噪。</a:t>
             </a:r>
           </a:p>
           <a:p>
             <a:pPr lvl="1"/>
             <a:r>
-              <a:rPr lang="zh-CN" altLang="zh-CN" sz="2000" dirty="0"/>
+              <a:rPr lang="zh-CN" altLang="zh-CN" dirty="0"/>
               <a:t>ddpm的</a:t>
             </a:r>
             <a:r>
-              <a:rPr lang="zh-CN" altLang="zh-CN" sz="2000" b="1" dirty="0"/>
+              <a:rPr lang="zh-CN" altLang="zh-CN" b="1" dirty="0"/>
               <a:t>去噪过程</a:t>
             </a:r>
             <a:r>
-              <a:rPr lang="zh-CN" altLang="zh-CN" sz="2000" dirty="0"/>
+              <a:rPr lang="zh-CN" altLang="zh-CN" dirty="0"/>
               <a:t>是通过模型预测噪声，通过预测的噪声，一步步推出  , VQ-diffusion是通过模型预测临时的  ,通过时间步一步步推出最终 。</a:t>
             </a:r>
           </a:p>
           <a:p>
             <a:pPr lvl="1"/>
             <a:r>
-              <a:rPr lang="zh-CN" altLang="zh-CN" sz="2000" dirty="0"/>
+              <a:rPr lang="zh-CN" altLang="zh-CN" dirty="0"/>
               <a:t>ddpm的</a:t>
             </a:r>
             <a:r>
-              <a:rPr lang="zh-CN" altLang="zh-CN" sz="2000" b="1" dirty="0"/>
+              <a:rPr lang="zh-CN" altLang="zh-CN" b="1" dirty="0"/>
               <a:t>损失函数</a:t>
             </a:r>
             <a:r>
-              <a:rPr lang="zh-CN" altLang="zh-CN" sz="2000" dirty="0"/>
+              <a:rPr lang="zh-CN" altLang="zh-CN" dirty="0"/>
               <a:t>是优化 </a:t>
             </a:r>
             <a:r>
-              <a:rPr lang="zh-CN" altLang="zh-CN" sz="2000" b="1" dirty="0"/>
+              <a:rPr lang="zh-CN" altLang="zh-CN" b="1" dirty="0"/>
               <a:t>预测的噪声</a:t>
             </a:r>
             <a:r>
-              <a:rPr lang="zh-CN" altLang="zh-CN" sz="2000" dirty="0"/>
+              <a:rPr lang="zh-CN" altLang="zh-CN" dirty="0"/>
               <a:t>和</a:t>
             </a:r>
             <a:r>
-              <a:rPr lang="zh-CN" altLang="zh-CN" sz="2000" b="1" dirty="0"/>
+              <a:rPr lang="zh-CN" altLang="zh-CN" b="1" dirty="0"/>
               <a:t>实际加入的噪声</a:t>
             </a:r>
             <a:r>
-              <a:rPr lang="zh-CN" altLang="zh-CN" sz="2000" dirty="0"/>
+              <a:rPr lang="zh-CN" altLang="zh-CN" dirty="0"/>
               <a:t>之间的差值。VQ-diffusion是通过模型预测出的  推导出  ,之后优化  与  之间的KL散度来训练模型。</a:t>
             </a:r>
           </a:p>
           <a:p>
             <a:pPr lvl="1"/>
             <a:r>
-              <a:rPr lang="zh-CN" altLang="zh-CN" sz="2000" dirty="0"/>
+              <a:rPr lang="zh-CN" altLang="zh-CN" dirty="0"/>
               <a:t>VQ-diffusion在损失函数中加入了辅助loss(将临时预测的 和实际的  之间计算交叉熵)。</a:t>
             </a:r>
           </a:p>
@@ -4411,7 +4609,7 @@
 </p:sld>
 </file>
 
-<file path=ppt/slides/slide5.xml><?xml version="1.0" encoding="utf-8"?>
+<file path=ppt/slides/slide6.xml><?xml version="1.0" encoding="utf-8"?>
 <p:sld xmlns:a="http://schemas.openxmlformats.org/drawingml/2006/main" xmlns:r="http://schemas.openxmlformats.org/officeDocument/2006/relationships" xmlns:p="http://schemas.openxmlformats.org/presentationml/2006/main">
   <p:cSld>
     <p:spTree>

</xml_diff>

<commit_message>
test binary latent diffusion and research the gap between clean and adversial-attacked samples.
</commit_message>
<xml_diff>
--- a/CRIS_week14.pptx
+++ b/CRIS_week14.pptx
@@ -264,7 +264,7 @@
           <a:p>
             <a:fld id="{4E1F1B7E-6966-4D66-AF8F-551D238877EA}" type="datetimeFigureOut">
               <a:rPr lang="zh-CN" altLang="en-US" smtClean="0"/>
-              <a:t>2026/6/29</a:t>
+              <a:t>2026/7/4</a:t>
             </a:fld>
             <a:endParaRPr lang="zh-CN" altLang="en-US"/>
           </a:p>
@@ -462,7 +462,7 @@
           <a:p>
             <a:fld id="{4E1F1B7E-6966-4D66-AF8F-551D238877EA}" type="datetimeFigureOut">
               <a:rPr lang="zh-CN" altLang="en-US" smtClean="0"/>
-              <a:t>2026/6/29</a:t>
+              <a:t>2026/7/4</a:t>
             </a:fld>
             <a:endParaRPr lang="zh-CN" altLang="en-US"/>
           </a:p>
@@ -670,7 +670,7 @@
           <a:p>
             <a:fld id="{4E1F1B7E-6966-4D66-AF8F-551D238877EA}" type="datetimeFigureOut">
               <a:rPr lang="zh-CN" altLang="en-US" smtClean="0"/>
-              <a:t>2026/6/29</a:t>
+              <a:t>2026/7/4</a:t>
             </a:fld>
             <a:endParaRPr lang="zh-CN" altLang="en-US"/>
           </a:p>
@@ -868,7 +868,7 @@
           <a:p>
             <a:fld id="{4E1F1B7E-6966-4D66-AF8F-551D238877EA}" type="datetimeFigureOut">
               <a:rPr lang="zh-CN" altLang="en-US" smtClean="0"/>
-              <a:t>2026/6/29</a:t>
+              <a:t>2026/7/4</a:t>
             </a:fld>
             <a:endParaRPr lang="zh-CN" altLang="en-US"/>
           </a:p>
@@ -1143,7 +1143,7 @@
           <a:p>
             <a:fld id="{4E1F1B7E-6966-4D66-AF8F-551D238877EA}" type="datetimeFigureOut">
               <a:rPr lang="zh-CN" altLang="en-US" smtClean="0"/>
-              <a:t>2026/6/29</a:t>
+              <a:t>2026/7/4</a:t>
             </a:fld>
             <a:endParaRPr lang="zh-CN" altLang="en-US"/>
           </a:p>
@@ -1408,7 +1408,7 @@
           <a:p>
             <a:fld id="{4E1F1B7E-6966-4D66-AF8F-551D238877EA}" type="datetimeFigureOut">
               <a:rPr lang="zh-CN" altLang="en-US" smtClean="0"/>
-              <a:t>2026/6/29</a:t>
+              <a:t>2026/7/4</a:t>
             </a:fld>
             <a:endParaRPr lang="zh-CN" altLang="en-US"/>
           </a:p>
@@ -1820,7 +1820,7 @@
           <a:p>
             <a:fld id="{4E1F1B7E-6966-4D66-AF8F-551D238877EA}" type="datetimeFigureOut">
               <a:rPr lang="zh-CN" altLang="en-US" smtClean="0"/>
-              <a:t>2026/6/29</a:t>
+              <a:t>2026/7/4</a:t>
             </a:fld>
             <a:endParaRPr lang="zh-CN" altLang="en-US"/>
           </a:p>
@@ -1961,7 +1961,7 @@
           <a:p>
             <a:fld id="{4E1F1B7E-6966-4D66-AF8F-551D238877EA}" type="datetimeFigureOut">
               <a:rPr lang="zh-CN" altLang="en-US" smtClean="0"/>
-              <a:t>2026/6/29</a:t>
+              <a:t>2026/7/4</a:t>
             </a:fld>
             <a:endParaRPr lang="zh-CN" altLang="en-US"/>
           </a:p>
@@ -2074,7 +2074,7 @@
           <a:p>
             <a:fld id="{4E1F1B7E-6966-4D66-AF8F-551D238877EA}" type="datetimeFigureOut">
               <a:rPr lang="zh-CN" altLang="en-US" smtClean="0"/>
-              <a:t>2026/6/29</a:t>
+              <a:t>2026/7/4</a:t>
             </a:fld>
             <a:endParaRPr lang="zh-CN" altLang="en-US"/>
           </a:p>
@@ -2385,7 +2385,7 @@
           <a:p>
             <a:fld id="{4E1F1B7E-6966-4D66-AF8F-551D238877EA}" type="datetimeFigureOut">
               <a:rPr lang="zh-CN" altLang="en-US" smtClean="0"/>
-              <a:t>2026/6/29</a:t>
+              <a:t>2026/7/4</a:t>
             </a:fld>
             <a:endParaRPr lang="zh-CN" altLang="en-US"/>
           </a:p>
@@ -2673,7 +2673,7 @@
           <a:p>
             <a:fld id="{4E1F1B7E-6966-4D66-AF8F-551D238877EA}" type="datetimeFigureOut">
               <a:rPr lang="zh-CN" altLang="en-US" smtClean="0"/>
-              <a:t>2026/6/29</a:t>
+              <a:t>2026/7/4</a:t>
             </a:fld>
             <a:endParaRPr lang="zh-CN" altLang="en-US"/>
           </a:p>
@@ -2914,7 +2914,7 @@
           <a:p>
             <a:fld id="{4E1F1B7E-6966-4D66-AF8F-551D238877EA}" type="datetimeFigureOut">
               <a:rPr lang="zh-CN" altLang="en-US" smtClean="0"/>
-              <a:t>2026/6/29</a:t>
+              <a:t>2026/7/4</a:t>
             </a:fld>
             <a:endParaRPr lang="zh-CN" altLang="en-US"/>
           </a:p>
@@ -4349,7 +4349,7 @@
             </a:r>
             <a:r>
               <a:rPr lang="zh-CN" altLang="en-US" dirty="0"/>
-              <a:t>可以正常推到，训练慕白哦也与</a:t>
+              <a:t>可以正常推到，训练目标也与</a:t>
             </a:r>
             <a:r>
               <a:rPr lang="en-US" altLang="zh-CN" dirty="0"/>

</xml_diff>